<commit_message>
Fixed QA issues: TAM formula, Boeing tenure (15 years), margin % (27-33%)
</commit_message>
<xml_diff>
--- a/pitch/MOTRA-Pitch-Deck-v2.pptx
+++ b/pitch/MOTRA-Pitch-Deck-v2.pptx
@@ -3632,7 +3632,7 @@
               </a:defRPr>
             </a:pPr>
             <a:r>
-              <a:t>14 years 8 months at Boeing</a:t>
+              <a:t>15 years at Boeing</a:t>
             </a:r>
           </a:p>
         </p:txBody>
@@ -6249,7 +6249,7 @@
               </a:defRPr>
             </a:pPr>
             <a:r>
-              <a:t>25-35%</a:t>
+              <a:t>27-33%</a:t>
             </a:r>
           </a:p>
         </p:txBody>
@@ -12143,7 +12143,7 @@
               </a:defRPr>
             </a:pPr>
             <a:r>
-              <a:t>50K robotaxis × $30/week</a:t>
+              <a:t>100K robotaxis × ~$105/week</a:t>
             </a:r>
           </a:p>
         </p:txBody>

</xml_diff>